<commit_message>
docs: switch report to 16:9 with column chart
- Widescreen 16:9 canvas (13.333x7.5in)
- NIST risk focus now uses a column/bar chart instead of a pie
- No logo (confidentiality); all data remains synthetic
</commit_message>
<xml_diff>
--- a/docs/Informe_Asignaciones.pptx
+++ b/docs/Informe_Asignaciones.pptx
@@ -10,7 +10,7 @@
     <p:sldId id="258" r:id="rId9"/>
     <p:sldId id="259" r:id="rId10"/>
   </p:sldIdLst>
-  <p:sldSz cx="9144000" cy="6858000" type="screen4x3"/>
+  <p:sldSz cx="12192000" cy="6858000" type="screen4x3"/>
   <p:notesSz cx="6858000" cy="9144000"/>
   <p:defaultTextStyle>
     <a:defPPr>
@@ -112,6 +112,7 @@
 
 <file path=ppt/charts/chart1.xml><?xml version="1.0" encoding="utf-8"?>
 <c:chartSpace xmlns:c="http://schemas.openxmlformats.org/drawingml/2006/chart" xmlns:a="http://schemas.openxmlformats.org/drawingml/2006/main" xmlns:r="http://schemas.openxmlformats.org/officeDocument/2006/relationships">
+  <c:date1904 val="0"/>
   <c:chart>
     <c:title>
       <c:tx>
@@ -120,7 +121,7 @@
           <a:lstStyle/>
           <a:p>
             <a:r>
-              <a:t>Capacidad del equipo por nivel de riesgo</a:t>
+              <a:t>Capacidad del equipo por nivel de riesgo (pts)</a:t>
             </a:r>
           </a:p>
         </c:rich>
@@ -130,8 +131,9 @@
     </c:title>
     <c:autoTitleDeleted val="0"/>
     <c:plotArea>
-      <c:pieChart>
-        <c:varyColors val="1"/>
+      <c:barChart>
+        <c:barDir val="col"/>
+        <c:grouping val="clustered"/>
         <c:ser>
           <c:idx val="0"/>
           <c:order val="0"/>
@@ -182,9 +184,39 @@
             </c:numRef>
           </c:val>
         </c:ser>
-      </c:pieChart>
+        <c:axId val="-2068027336"/>
+        <c:axId val="-2113994440"/>
+      </c:barChart>
+      <c:catAx>
+        <c:axId val="-2068027336"/>
+        <c:scaling>
+          <c:orientation val="minMax"/>
+        </c:scaling>
+        <c:delete val="0"/>
+        <c:axPos val="b"/>
+        <c:majorTickMark val="out"/>
+        <c:minorTickMark val="none"/>
+        <c:tickLblPos val="nextTo"/>
+        <c:crossAx val="-2113994440"/>
+        <c:crosses val="autoZero"/>
+        <c:auto val="1"/>
+        <c:lblAlgn val="ctr"/>
+        <c:lblOffset val="100"/>
+        <c:noMultiLvlLbl val="0"/>
+      </c:catAx>
+      <c:valAx>
+        <c:axId val="-2113994440"/>
+        <c:scaling/>
+        <c:delete val="0"/>
+        <c:axPos val="l"/>
+        <c:majorGridlines/>
+        <c:majorTickMark val="out"/>
+        <c:minorTickMark val="none"/>
+        <c:tickLblPos val="nextTo"/>
+        <c:crossAx val="-2068027336"/>
+        <c:crosses val="autoZero"/>
+      </c:valAx>
     </c:plotArea>
-    <c:legend/>
     <c:dispBlanksAs val="gap"/>
   </c:chart>
   <c:txPr>
@@ -3186,42 +3218,78 @@
       <p:grpSpPr/>
       <p:sp>
         <p:nvSpPr>
-          <p:cNvPr id="2" name="Title 1"/>
-          <p:cNvSpPr>
-            <a:spLocks noGrp="1"/>
-          </p:cNvSpPr>
-          <p:nvPr>
-            <p:ph type="ctrTitle"/>
-          </p:nvPr>
-        </p:nvSpPr>
-        <p:spPr/>
-        <p:txBody>
-          <a:bodyPr/>
-          <a:lstStyle/>
-          <a:p>
-            <a:r>
+          <p:cNvPr id="2" name="Rectangle 1"/>
+          <p:cNvSpPr/>
+          <p:nvPr/>
+        </p:nvSpPr>
+        <p:spPr>
+          <a:xfrm>
+            <a:off x="731520" y="2148840"/>
+            <a:ext cx="2926080" cy="91440"/>
+          </a:xfrm>
+          <a:prstGeom prst="rect">
+            <a:avLst/>
+          </a:prstGeom>
+          <a:solidFill>
+            <a:srgbClr val="2563EB"/>
+          </a:solidFill>
+          <a:ln>
+            <a:solidFill>
+              <a:srgbClr val="2563EB"/>
+            </a:solidFill>
+          </a:ln>
+        </p:spPr>
+        <p:style>
+          <a:lnRef idx="1">
+            <a:schemeClr val="accent1"/>
+          </a:lnRef>
+          <a:fillRef idx="3">
+            <a:schemeClr val="accent1"/>
+          </a:fillRef>
+          <a:effectRef idx="2">
+            <a:schemeClr val="accent1"/>
+          </a:effectRef>
+          <a:fontRef idx="minor">
+            <a:schemeClr val="lt1"/>
+          </a:fontRef>
+        </p:style>
+        <p:txBody>
+          <a:bodyPr rtlCol="0" anchor="ctr"/>
+          <a:lstStyle/>
+          <a:p>
+            <a:pPr algn="ctr"/>
+          </a:p>
+        </p:txBody>
+      </p:sp>
+      <p:sp>
+        <p:nvSpPr>
+          <p:cNvPr id="3" name="TextBox 2"/>
+          <p:cNvSpPr txBox="1"/>
+          <p:nvPr/>
+        </p:nvSpPr>
+        <p:spPr>
+          <a:xfrm>
+            <a:off x="731520" y="2377440"/>
+            <a:ext cx="10698480" cy="1371600"/>
+          </a:xfrm>
+          <a:prstGeom prst="rect">
+            <a:avLst/>
+          </a:prstGeom>
+          <a:noFill/>
+        </p:spPr>
+        <p:txBody>
+          <a:bodyPr wrap="square">
+            <a:spAutoFit/>
+          </a:bodyPr>
+          <a:lstStyle/>
+          <a:p>
+            <a:r>
+              <a:rPr sz="4200" b="1">
+                <a:solidFill>
+                  <a:srgbClr val="0F203C"/>
+                </a:solidFill>
+              </a:rPr>
               <a:t>Informe de Asignaciones del Equipo de IA</a:t>
-            </a:r>
-          </a:p>
-        </p:txBody>
-      </p:sp>
-      <p:sp>
-        <p:nvSpPr>
-          <p:cNvPr id="3" name="Subtitle 2"/>
-          <p:cNvSpPr>
-            <a:spLocks noGrp="1"/>
-          </p:cNvSpPr>
-          <p:nvPr>
-            <p:ph type="subTitle" idx="1"/>
-          </p:nvPr>
-        </p:nvSpPr>
-        <p:spPr/>
-        <p:txBody>
-          <a:bodyPr/>
-          <a:lstStyle/>
-          <a:p>
-            <a:r>
-              <a:t>Datos sintéticos de demostración</a:t>
             </a:r>
           </a:p>
         </p:txBody>
@@ -3234,7 +3302,40 @@
         </p:nvSpPr>
         <p:spPr>
           <a:xfrm>
-            <a:off x="822960" y="5852160"/>
+            <a:off x="731520" y="3794760"/>
+            <a:ext cx="10698480" cy="640080"/>
+          </a:xfrm>
+          <a:prstGeom prst="rect">
+            <a:avLst/>
+          </a:prstGeom>
+          <a:noFill/>
+        </p:spPr>
+        <p:txBody>
+          <a:bodyPr wrap="square">
+            <a:spAutoFit/>
+          </a:bodyPr>
+          <a:lstStyle/>
+          <a:p>
+            <a:r>
+              <a:rPr sz="2200">
+                <a:solidFill>
+                  <a:srgbClr val="2563EB"/>
+                </a:solidFill>
+              </a:rPr>
+              <a:t>Datos sintéticos de demostración</a:t>
+            </a:r>
+          </a:p>
+        </p:txBody>
+      </p:sp>
+      <p:sp>
+        <p:nvSpPr>
+          <p:cNvPr id="5" name="TextBox 4"/>
+          <p:cNvSpPr txBox="1"/>
+          <p:nvPr/>
+        </p:nvSpPr>
+        <p:spPr>
+          <a:xfrm>
+            <a:off x="731520" y="4572000"/>
             <a:ext cx="7315200" cy="457200"/>
           </a:xfrm>
           <a:prstGeom prst="rect">
@@ -3251,7 +3352,7 @@
             <a:r>
               <a:rPr sz="1600" i="1">
                 <a:solidFill>
-                  <a:srgbClr val="2563EB"/>
+                  <a:srgbClr val="5A5A5A"/>
                 </a:solidFill>
               </a:rPr>
               <a:t>22 de septiembre de 2026</a:t>
@@ -3261,14 +3362,14 @@
       </p:sp>
       <p:sp>
         <p:nvSpPr>
-          <p:cNvPr id="5" name="TextBox 4"/>
+          <p:cNvPr id="6" name="TextBox 5"/>
           <p:cNvSpPr txBox="1"/>
           <p:nvPr/>
         </p:nvSpPr>
         <p:spPr>
           <a:xfrm>
-            <a:off x="822960" y="6263640"/>
-            <a:ext cx="7772400" cy="365760"/>
+            <a:off x="731520" y="6172200"/>
+            <a:ext cx="10698480" cy="365760"/>
           </a:xfrm>
           <a:prstGeom prst="rect">
             <a:avLst/>
@@ -3284,7 +3385,7 @@
             <a:r>
               <a:rPr sz="1100">
                 <a:solidFill>
-                  <a:srgbClr val="787878"/>
+                  <a:srgbClr val="8C8C8C"/>
                 </a:solidFill>
               </a:rPr>
               <a:t>Todos los nombres, casos de uso y cifras son ficticios.</a:t>
@@ -3312,20 +3413,77 @@
       <p:grpSpPr/>
       <p:sp>
         <p:nvSpPr>
-          <p:cNvPr id="2" name="Title 1"/>
-          <p:cNvSpPr>
-            <a:spLocks noGrp="1"/>
-          </p:cNvSpPr>
-          <p:nvPr>
-            <p:ph type="title"/>
-          </p:nvPr>
-        </p:nvSpPr>
-        <p:spPr/>
-        <p:txBody>
-          <a:bodyPr/>
-          <a:lstStyle/>
-          <a:p>
-            <a:r>
+          <p:cNvPr id="2" name="Rectangle 1"/>
+          <p:cNvSpPr/>
+          <p:nvPr/>
+        </p:nvSpPr>
+        <p:spPr>
+          <a:xfrm>
+            <a:off x="548640" y="502920"/>
+            <a:ext cx="128016" cy="658368"/>
+          </a:xfrm>
+          <a:prstGeom prst="rect">
+            <a:avLst/>
+          </a:prstGeom>
+          <a:solidFill>
+            <a:srgbClr val="2563EB"/>
+          </a:solidFill>
+          <a:ln>
+            <a:solidFill>
+              <a:srgbClr val="2563EB"/>
+            </a:solidFill>
+          </a:ln>
+        </p:spPr>
+        <p:style>
+          <a:lnRef idx="1">
+            <a:schemeClr val="accent1"/>
+          </a:lnRef>
+          <a:fillRef idx="3">
+            <a:schemeClr val="accent1"/>
+          </a:fillRef>
+          <a:effectRef idx="2">
+            <a:schemeClr val="accent1"/>
+          </a:effectRef>
+          <a:fontRef idx="minor">
+            <a:schemeClr val="lt1"/>
+          </a:fontRef>
+        </p:style>
+        <p:txBody>
+          <a:bodyPr rtlCol="0" anchor="ctr"/>
+          <a:lstStyle/>
+          <a:p>
+            <a:pPr algn="ctr"/>
+          </a:p>
+        </p:txBody>
+      </p:sp>
+      <p:sp>
+        <p:nvSpPr>
+          <p:cNvPr id="3" name="TextBox 2"/>
+          <p:cNvSpPr txBox="1"/>
+          <p:nvPr/>
+        </p:nvSpPr>
+        <p:spPr>
+          <a:xfrm>
+            <a:off x="822960" y="457200"/>
+            <a:ext cx="10789920" cy="777240"/>
+          </a:xfrm>
+          <a:prstGeom prst="rect">
+            <a:avLst/>
+          </a:prstGeom>
+          <a:noFill/>
+        </p:spPr>
+        <p:txBody>
+          <a:bodyPr wrap="square">
+            <a:spAutoFit/>
+          </a:bodyPr>
+          <a:lstStyle/>
+          <a:p>
+            <a:r>
+              <a:rPr sz="3000" b="1">
+                <a:solidFill>
+                  <a:srgbClr val="0F203C"/>
+                </a:solidFill>
+              </a:rPr>
               <a:t>Carga por persona</a:t>
             </a:r>
           </a:p>
@@ -3333,15 +3491,15 @@
       </p:sp>
       <p:graphicFrame>
         <p:nvGraphicFramePr>
-          <p:cNvPr id="3" name="Table 2"/>
+          <p:cNvPr id="4" name="Table 3"/>
           <p:cNvGraphicFramePr>
             <a:graphicFrameLocks noGrp="1"/>
           </p:cNvGraphicFramePr>
           <p:nvPr/>
         </p:nvGraphicFramePr>
         <p:xfrm>
-          <a:off x="457200" y="1554480"/>
-          <a:ext cx="8229600" cy="4206240"/>
+          <a:off x="548640" y="1554480"/>
+          <a:ext cx="11064240" cy="4114800"/>
         </p:xfrm>
         <a:graphic>
           <a:graphicData uri="http://schemas.openxmlformats.org/drawingml/2006/table">
@@ -3350,19 +3508,19 @@
                 <a:tableStyleId>{5C22544A-7EE6-4342-B048-85BDC9FD1C3A}</a:tableStyleId>
               </a:tblPr>
               <a:tblGrid>
-                <a:gridCol w="2057400"/>
-                <a:gridCol w="2057400"/>
-                <a:gridCol w="2057400"/>
-                <a:gridCol w="2057400"/>
+                <a:gridCol w="2766060"/>
+                <a:gridCol w="2766060"/>
+                <a:gridCol w="2766060"/>
+                <a:gridCol w="2766060"/>
               </a:tblGrid>
-              <a:tr h="600891">
+              <a:tr h="587828">
                 <a:tc>
                   <a:txBody>
                     <a:bodyPr wrap="square"/>
                     <a:lstStyle/>
                     <a:p>
                       <a:r>
-                        <a:rPr sz="1500" b="1"/>
+                        <a:rPr sz="1600" b="1"/>
                         <a:t>Nombre</a:t>
                       </a:r>
                     </a:p>
@@ -3379,7 +3537,7 @@
                     <a:lstStyle/>
                     <a:p>
                       <a:r>
-                        <a:rPr sz="1500" b="1"/>
+                        <a:rPr sz="1600" b="1"/>
                         <a:t>Rol</a:t>
                       </a:r>
                     </a:p>
@@ -3396,7 +3554,7 @@
                     <a:lstStyle/>
                     <a:p>
                       <a:r>
-                        <a:rPr sz="1500" b="1"/>
+                        <a:rPr sz="1600" b="1"/>
                         <a:t>% dedicación total</a:t>
                       </a:r>
                     </a:p>
@@ -3413,7 +3571,7 @@
                     <a:lstStyle/>
                     <a:p>
                       <a:r>
-                        <a:rPr sz="1500" b="1"/>
+                        <a:rPr sz="1600" b="1"/>
                         <a:t>Estado (semáforo)</a:t>
                       </a:r>
                     </a:p>
@@ -3425,14 +3583,14 @@
                   </a:tcPr>
                 </a:tc>
               </a:tr>
-              <a:tr h="600891">
+              <a:tr h="587828">
                 <a:tc>
                   <a:txBody>
                     <a:bodyPr wrap="square"/>
                     <a:lstStyle/>
                     <a:p>
                       <a:r>
-                        <a:rPr sz="1400"/>
+                        <a:rPr sz="1500"/>
                         <a:t>Lucía Marín</a:t>
                       </a:r>
                     </a:p>
@@ -3449,7 +3607,7 @@
                     <a:lstStyle/>
                     <a:p>
                       <a:r>
-                        <a:rPr sz="1400"/>
+                        <a:rPr sz="1500"/>
                         <a:t>ML Engineer</a:t>
                       </a:r>
                     </a:p>
@@ -3467,7 +3625,7 @@
                     <a:p>
                       <a:pPr algn="ctr"/>
                       <a:r>
-                        <a:rPr sz="1400"/>
+                        <a:rPr sz="1500"/>
                         <a:t>90%</a:t>
                       </a:r>
                     </a:p>
@@ -3485,7 +3643,7 @@
                     <a:p>
                       <a:pPr algn="ctr"/>
                       <a:r>
-                        <a:rPr sz="1400" b="1">
+                        <a:rPr sz="1500" b="1">
                           <a:solidFill>
                             <a:srgbClr val="FFFFFF"/>
                           </a:solidFill>
@@ -3501,14 +3659,14 @@
                   </a:tcPr>
                 </a:tc>
               </a:tr>
-              <a:tr h="600891">
+              <a:tr h="587828">
                 <a:tc>
                   <a:txBody>
                     <a:bodyPr wrap="square"/>
                     <a:lstStyle/>
                     <a:p>
                       <a:r>
-                        <a:rPr sz="1400"/>
+                        <a:rPr sz="1500"/>
                         <a:t>Diego Ferrán</a:t>
                       </a:r>
                     </a:p>
@@ -3525,7 +3683,7 @@
                     <a:lstStyle/>
                     <a:p>
                       <a:r>
-                        <a:rPr sz="1400"/>
+                        <a:rPr sz="1500"/>
                         <a:t>Data Scientist</a:t>
                       </a:r>
                     </a:p>
@@ -3543,7 +3701,7 @@
                     <a:p>
                       <a:pPr algn="ctr"/>
                       <a:r>
-                        <a:rPr sz="1400"/>
+                        <a:rPr sz="1500"/>
                         <a:t>90%</a:t>
                       </a:r>
                     </a:p>
@@ -3561,7 +3719,7 @@
                     <a:p>
                       <a:pPr algn="ctr"/>
                       <a:r>
-                        <a:rPr sz="1400" b="1">
+                        <a:rPr sz="1500" b="1">
                           <a:solidFill>
                             <a:srgbClr val="FFFFFF"/>
                           </a:solidFill>
@@ -3577,14 +3735,14 @@
                   </a:tcPr>
                 </a:tc>
               </a:tr>
-              <a:tr h="600891">
+              <a:tr h="587828">
                 <a:tc>
                   <a:txBody>
                     <a:bodyPr wrap="square"/>
                     <a:lstStyle/>
                     <a:p>
                       <a:r>
-                        <a:rPr sz="1400"/>
+                        <a:rPr sz="1500"/>
                         <a:t>Aisha Nassiri</a:t>
                       </a:r>
                     </a:p>
@@ -3601,7 +3759,7 @@
                     <a:lstStyle/>
                     <a:p>
                       <a:r>
-                        <a:rPr sz="1400"/>
+                        <a:rPr sz="1500"/>
                         <a:t>MLOps Engineer</a:t>
                       </a:r>
                     </a:p>
@@ -3619,7 +3777,7 @@
                     <a:p>
                       <a:pPr algn="ctr"/>
                       <a:r>
-                        <a:rPr sz="1400"/>
+                        <a:rPr sz="1500"/>
                         <a:t>115%</a:t>
                       </a:r>
                     </a:p>
@@ -3637,7 +3795,7 @@
                     <a:p>
                       <a:pPr algn="ctr"/>
                       <a:r>
-                        <a:rPr sz="1400" b="1">
+                        <a:rPr sz="1500" b="1">
                           <a:solidFill>
                             <a:srgbClr val="FFFFFF"/>
                           </a:solidFill>
@@ -3653,14 +3811,14 @@
                   </a:tcPr>
                 </a:tc>
               </a:tr>
-              <a:tr h="600891">
+              <a:tr h="587828">
                 <a:tc>
                   <a:txBody>
                     <a:bodyPr wrap="square"/>
                     <a:lstStyle/>
                     <a:p>
                       <a:r>
-                        <a:rPr sz="1400"/>
+                        <a:rPr sz="1500"/>
                         <a:t>Bruno Salgado</a:t>
                       </a:r>
                     </a:p>
@@ -3677,7 +3835,7 @@
                     <a:lstStyle/>
                     <a:p>
                       <a:r>
-                        <a:rPr sz="1400"/>
+                        <a:rPr sz="1500"/>
                         <a:t>AI Product Manager</a:t>
                       </a:r>
                     </a:p>
@@ -3695,7 +3853,7 @@
                     <a:p>
                       <a:pPr algn="ctr"/>
                       <a:r>
-                        <a:rPr sz="1400"/>
+                        <a:rPr sz="1500"/>
                         <a:t>50%</a:t>
                       </a:r>
                     </a:p>
@@ -3713,7 +3871,7 @@
                     <a:p>
                       <a:pPr algn="ctr"/>
                       <a:r>
-                        <a:rPr sz="1400" b="1">
+                        <a:rPr sz="1500" b="1">
                           <a:solidFill>
                             <a:srgbClr val="FFFFFF"/>
                           </a:solidFill>
@@ -3729,14 +3887,14 @@
                   </a:tcPr>
                 </a:tc>
               </a:tr>
-              <a:tr h="600891">
+              <a:tr h="587828">
                 <a:tc>
                   <a:txBody>
                     <a:bodyPr wrap="square"/>
                     <a:lstStyle/>
                     <a:p>
                       <a:r>
-                        <a:rPr sz="1400"/>
+                        <a:rPr sz="1500"/>
                         <a:t>Yuki Tanaka</a:t>
                       </a:r>
                     </a:p>
@@ -3753,7 +3911,7 @@
                     <a:lstStyle/>
                     <a:p>
                       <a:r>
-                        <a:rPr sz="1400"/>
+                        <a:rPr sz="1500"/>
                         <a:t>Responsible AI Lead</a:t>
                       </a:r>
                     </a:p>
@@ -3771,7 +3929,7 @@
                     <a:p>
                       <a:pPr algn="ctr"/>
                       <a:r>
-                        <a:rPr sz="1400"/>
+                        <a:rPr sz="1500"/>
                         <a:t>70%</a:t>
                       </a:r>
                     </a:p>
@@ -3789,7 +3947,7 @@
                     <a:p>
                       <a:pPr algn="ctr"/>
                       <a:r>
-                        <a:rPr sz="1400" b="1">
+                        <a:rPr sz="1500" b="1">
                           <a:solidFill>
                             <a:srgbClr val="FFFFFF"/>
                           </a:solidFill>
@@ -3805,14 +3963,14 @@
                   </a:tcPr>
                 </a:tc>
               </a:tr>
-              <a:tr h="600894">
+              <a:tr h="587832">
                 <a:tc>
                   <a:txBody>
                     <a:bodyPr wrap="square"/>
                     <a:lstStyle/>
                     <a:p>
                       <a:r>
-                        <a:rPr sz="1400"/>
+                        <a:rPr sz="1500"/>
                         <a:t>Elena Rossi</a:t>
                       </a:r>
                     </a:p>
@@ -3829,7 +3987,7 @@
                     <a:lstStyle/>
                     <a:p>
                       <a:r>
-                        <a:rPr sz="1400"/>
+                        <a:rPr sz="1500"/>
                         <a:t>Prompt Engineer</a:t>
                       </a:r>
                     </a:p>
@@ -3847,7 +4005,7 @@
                     <a:p>
                       <a:pPr algn="ctr"/>
                       <a:r>
-                        <a:rPr sz="1400"/>
+                        <a:rPr sz="1500"/>
                         <a:t>55%</a:t>
                       </a:r>
                     </a:p>
@@ -3865,7 +4023,7 @@
                     <a:p>
                       <a:pPr algn="ctr"/>
                       <a:r>
-                        <a:rPr sz="1400" b="1">
+                        <a:rPr sz="1500" b="1">
                           <a:solidFill>
                             <a:srgbClr val="FFFFFF"/>
                           </a:solidFill>
@@ -3887,14 +4045,14 @@
       </p:graphicFrame>
       <p:sp>
         <p:nvSpPr>
-          <p:cNvPr id="4" name="TextBox 3"/>
+          <p:cNvPr id="5" name="TextBox 4"/>
           <p:cNvSpPr txBox="1"/>
           <p:nvPr/>
         </p:nvSpPr>
         <p:spPr>
           <a:xfrm>
-            <a:off x="457200" y="5943600"/>
-            <a:ext cx="8229600" cy="548640"/>
+            <a:off x="548640" y="5943600"/>
+            <a:ext cx="11064240" cy="457200"/>
           </a:xfrm>
           <a:prstGeom prst="rect">
             <a:avLst/>
@@ -3938,20 +4096,77 @@
       <p:grpSpPr/>
       <p:sp>
         <p:nvSpPr>
-          <p:cNvPr id="2" name="Title 1"/>
-          <p:cNvSpPr>
-            <a:spLocks noGrp="1"/>
-          </p:cNvSpPr>
-          <p:nvPr>
-            <p:ph type="title"/>
-          </p:nvPr>
-        </p:nvSpPr>
-        <p:spPr/>
-        <p:txBody>
-          <a:bodyPr/>
-          <a:lstStyle/>
-          <a:p>
-            <a:r>
+          <p:cNvPr id="2" name="Rectangle 1"/>
+          <p:cNvSpPr/>
+          <p:nvPr/>
+        </p:nvSpPr>
+        <p:spPr>
+          <a:xfrm>
+            <a:off x="548640" y="502920"/>
+            <a:ext cx="128016" cy="658368"/>
+          </a:xfrm>
+          <a:prstGeom prst="rect">
+            <a:avLst/>
+          </a:prstGeom>
+          <a:solidFill>
+            <a:srgbClr val="2563EB"/>
+          </a:solidFill>
+          <a:ln>
+            <a:solidFill>
+              <a:srgbClr val="2563EB"/>
+            </a:solidFill>
+          </a:ln>
+        </p:spPr>
+        <p:style>
+          <a:lnRef idx="1">
+            <a:schemeClr val="accent1"/>
+          </a:lnRef>
+          <a:fillRef idx="3">
+            <a:schemeClr val="accent1"/>
+          </a:fillRef>
+          <a:effectRef idx="2">
+            <a:schemeClr val="accent1"/>
+          </a:effectRef>
+          <a:fontRef idx="minor">
+            <a:schemeClr val="lt1"/>
+          </a:fontRef>
+        </p:style>
+        <p:txBody>
+          <a:bodyPr rtlCol="0" anchor="ctr"/>
+          <a:lstStyle/>
+          <a:p>
+            <a:pPr algn="ctr"/>
+          </a:p>
+        </p:txBody>
+      </p:sp>
+      <p:sp>
+        <p:nvSpPr>
+          <p:cNvPr id="3" name="TextBox 2"/>
+          <p:cNvSpPr txBox="1"/>
+          <p:nvPr/>
+        </p:nvSpPr>
+        <p:spPr>
+          <a:xfrm>
+            <a:off x="822960" y="457200"/>
+            <a:ext cx="10789920" cy="777240"/>
+          </a:xfrm>
+          <a:prstGeom prst="rect">
+            <a:avLst/>
+          </a:prstGeom>
+          <a:noFill/>
+        </p:spPr>
+        <p:txBody>
+          <a:bodyPr wrap="square">
+            <a:spAutoFit/>
+          </a:bodyPr>
+          <a:lstStyle/>
+          <a:p>
+            <a:r>
+              <a:rPr sz="3000" b="1">
+                <a:solidFill>
+                  <a:srgbClr val="0F203C"/>
+                </a:solidFill>
+              </a:rPr>
               <a:t>Foco por riesgo (NIST)</a:t>
             </a:r>
           </a:p>
@@ -3959,15 +4174,15 @@
       </p:sp>
       <p:graphicFrame>
         <p:nvGraphicFramePr>
-          <p:cNvPr id="3" name="Table 2"/>
+          <p:cNvPr id="4" name="Table 3"/>
           <p:cNvGraphicFramePr>
             <a:graphicFrameLocks noGrp="1"/>
           </p:cNvGraphicFramePr>
           <p:nvPr/>
         </p:nvGraphicFramePr>
         <p:xfrm>
-          <a:off x="457200" y="1645920"/>
-          <a:ext cx="4023360" cy="2926080"/>
+          <a:off x="548640" y="1737360"/>
+          <a:ext cx="4937760" cy="2743200"/>
         </p:xfrm>
         <a:graphic>
           <a:graphicData uri="http://schemas.openxmlformats.org/drawingml/2006/table">
@@ -3976,18 +4191,18 @@
                 <a:tableStyleId>{5C22544A-7EE6-4342-B048-85BDC9FD1C3A}</a:tableStyleId>
               </a:tblPr>
               <a:tblGrid>
-                <a:gridCol w="1341120"/>
-                <a:gridCol w="1341120"/>
-                <a:gridCol w="1341120"/>
+                <a:gridCol w="1645920"/>
+                <a:gridCol w="1645920"/>
+                <a:gridCol w="1645920"/>
               </a:tblGrid>
-              <a:tr h="585216">
+              <a:tr h="548640">
                 <a:tc>
                   <a:txBody>
                     <a:bodyPr wrap="square"/>
                     <a:lstStyle/>
                     <a:p>
                       <a:r>
-                        <a:rPr sz="1400" b="1"/>
+                        <a:rPr sz="1500" b="1"/>
                         <a:t>Nivel de riesgo</a:t>
                       </a:r>
                     </a:p>
@@ -4004,7 +4219,7 @@
                     <a:lstStyle/>
                     <a:p>
                       <a:r>
-                        <a:rPr sz="1400" b="1"/>
+                        <a:rPr sz="1500" b="1"/>
                         <a:t>Capacidad (pts)</a:t>
                       </a:r>
                     </a:p>
@@ -4021,7 +4236,7 @@
                     <a:lstStyle/>
                     <a:p>
                       <a:r>
-                        <a:rPr sz="1400" b="1"/>
+                        <a:rPr sz="1500" b="1"/>
                         <a:t>% del total</a:t>
                       </a:r>
                     </a:p>
@@ -4033,14 +4248,14 @@
                   </a:tcPr>
                 </a:tc>
               </a:tr>
-              <a:tr h="585216">
+              <a:tr h="548640">
                 <a:tc>
                   <a:txBody>
                     <a:bodyPr wrap="square"/>
                     <a:lstStyle/>
                     <a:p>
                       <a:r>
-                        <a:rPr sz="1300"/>
+                        <a:rPr sz="1400"/>
                         <a:t>Bajo</a:t>
                       </a:r>
                     </a:p>
@@ -4057,7 +4272,7 @@
                     <a:lstStyle/>
                     <a:p>
                       <a:r>
-                        <a:rPr sz="1300"/>
+                        <a:rPr sz="1400"/>
                         <a:t>85</a:t>
                       </a:r>
                     </a:p>
@@ -4074,7 +4289,7 @@
                     <a:lstStyle/>
                     <a:p>
                       <a:r>
-                        <a:rPr sz="1300"/>
+                        <a:rPr sz="1400"/>
                         <a:t>18%</a:t>
                       </a:r>
                     </a:p>
@@ -4086,14 +4301,14 @@
                   </a:tcPr>
                 </a:tc>
               </a:tr>
-              <a:tr h="585216">
+              <a:tr h="548640">
                 <a:tc>
                   <a:txBody>
                     <a:bodyPr wrap="square"/>
                     <a:lstStyle/>
                     <a:p>
                       <a:r>
-                        <a:rPr sz="1300"/>
+                        <a:rPr sz="1400"/>
                         <a:t>Medio</a:t>
                       </a:r>
                     </a:p>
@@ -4110,7 +4325,7 @@
                     <a:lstStyle/>
                     <a:p>
                       <a:r>
-                        <a:rPr sz="1300"/>
+                        <a:rPr sz="1400"/>
                         <a:t>160</a:t>
                       </a:r>
                     </a:p>
@@ -4127,7 +4342,7 @@
                     <a:lstStyle/>
                     <a:p>
                       <a:r>
-                        <a:rPr sz="1300"/>
+                        <a:rPr sz="1400"/>
                         <a:t>34%</a:t>
                       </a:r>
                     </a:p>
@@ -4139,14 +4354,14 @@
                   </a:tcPr>
                 </a:tc>
               </a:tr>
-              <a:tr h="585216">
+              <a:tr h="548640">
                 <a:tc>
                   <a:txBody>
                     <a:bodyPr wrap="square"/>
                     <a:lstStyle/>
                     <a:p>
                       <a:r>
-                        <a:rPr sz="1300"/>
+                        <a:rPr sz="1400"/>
                         <a:t>Alto</a:t>
                       </a:r>
                     </a:p>
@@ -4163,7 +4378,7 @@
                     <a:lstStyle/>
                     <a:p>
                       <a:r>
-                        <a:rPr sz="1300"/>
+                        <a:rPr sz="1400"/>
                         <a:t>225</a:t>
                       </a:r>
                     </a:p>
@@ -4180,7 +4395,7 @@
                     <a:lstStyle/>
                     <a:p>
                       <a:r>
-                        <a:rPr sz="1300"/>
+                        <a:rPr sz="1400"/>
                         <a:t>48%</a:t>
                       </a:r>
                     </a:p>
@@ -4192,14 +4407,14 @@
                   </a:tcPr>
                 </a:tc>
               </a:tr>
-              <a:tr h="585216">
+              <a:tr h="548640">
                 <a:tc>
                   <a:txBody>
                     <a:bodyPr wrap="square"/>
                     <a:lstStyle/>
                     <a:p>
                       <a:r>
-                        <a:rPr sz="1300"/>
+                        <a:rPr sz="1400"/>
                         <a:t>Total</a:t>
                       </a:r>
                     </a:p>
@@ -4216,7 +4431,7 @@
                     <a:lstStyle/>
                     <a:p>
                       <a:r>
-                        <a:rPr sz="1300"/>
+                        <a:rPr sz="1400"/>
                         <a:t>470</a:t>
                       </a:r>
                     </a:p>
@@ -4233,7 +4448,7 @@
                     <a:lstStyle/>
                     <a:p>
                       <a:r>
-                        <a:rPr sz="1300"/>
+                        <a:rPr sz="1400"/>
                         <a:t>100%</a:t>
                       </a:r>
                     </a:p>
@@ -4251,15 +4466,15 @@
       </p:graphicFrame>
       <p:graphicFrame>
         <p:nvGraphicFramePr>
-          <p:cNvPr id="4" name="Chart 3"/>
+          <p:cNvPr id="5" name="Chart 4"/>
           <p:cNvGraphicFramePr>
             <a:graphicFrameLocks noGrp="1"/>
           </p:cNvGraphicFramePr>
           <p:nvPr/>
         </p:nvGraphicFramePr>
         <p:xfrm>
-          <a:off x="4663440" y="1371600"/>
-          <a:ext cx="4023360" cy="3931920"/>
+          <a:off x="5943600" y="1463040"/>
+          <a:ext cx="5669280" cy="4114800"/>
         </p:xfrm>
         <a:graphic>
           <a:graphicData uri="http://schemas.openxmlformats.org/drawingml/2006/chart">
@@ -4269,14 +4484,14 @@
       </p:graphicFrame>
       <p:sp>
         <p:nvSpPr>
-          <p:cNvPr id="5" name="TextBox 4"/>
+          <p:cNvPr id="6" name="TextBox 5"/>
           <p:cNvSpPr txBox="1"/>
           <p:nvPr/>
         </p:nvSpPr>
         <p:spPr>
           <a:xfrm>
-            <a:off x="457200" y="4754880"/>
-            <a:ext cx="4023360" cy="1097280"/>
+            <a:off x="548640" y="4754880"/>
+            <a:ext cx="4937760" cy="1188720"/>
           </a:xfrm>
           <a:prstGeom prst="rect">
             <a:avLst/>
@@ -4320,20 +4535,77 @@
       <p:grpSpPr/>
       <p:sp>
         <p:nvSpPr>
-          <p:cNvPr id="2" name="Title 1"/>
-          <p:cNvSpPr>
-            <a:spLocks noGrp="1"/>
-          </p:cNvSpPr>
-          <p:nvPr>
-            <p:ph type="title"/>
-          </p:nvPr>
-        </p:nvSpPr>
-        <p:spPr/>
-        <p:txBody>
-          <a:bodyPr/>
-          <a:lstStyle/>
-          <a:p>
-            <a:r>
+          <p:cNvPr id="2" name="Rectangle 1"/>
+          <p:cNvSpPr/>
+          <p:nvPr/>
+        </p:nvSpPr>
+        <p:spPr>
+          <a:xfrm>
+            <a:off x="548640" y="502920"/>
+            <a:ext cx="128016" cy="658368"/>
+          </a:xfrm>
+          <a:prstGeom prst="rect">
+            <a:avLst/>
+          </a:prstGeom>
+          <a:solidFill>
+            <a:srgbClr val="2563EB"/>
+          </a:solidFill>
+          <a:ln>
+            <a:solidFill>
+              <a:srgbClr val="2563EB"/>
+            </a:solidFill>
+          </a:ln>
+        </p:spPr>
+        <p:style>
+          <a:lnRef idx="1">
+            <a:schemeClr val="accent1"/>
+          </a:lnRef>
+          <a:fillRef idx="3">
+            <a:schemeClr val="accent1"/>
+          </a:fillRef>
+          <a:effectRef idx="2">
+            <a:schemeClr val="accent1"/>
+          </a:effectRef>
+          <a:fontRef idx="minor">
+            <a:schemeClr val="lt1"/>
+          </a:fontRef>
+        </p:style>
+        <p:txBody>
+          <a:bodyPr rtlCol="0" anchor="ctr"/>
+          <a:lstStyle/>
+          <a:p>
+            <a:pPr algn="ctr"/>
+          </a:p>
+        </p:txBody>
+      </p:sp>
+      <p:sp>
+        <p:nvSpPr>
+          <p:cNvPr id="3" name="TextBox 2"/>
+          <p:cNvSpPr txBox="1"/>
+          <p:nvPr/>
+        </p:nvSpPr>
+        <p:spPr>
+          <a:xfrm>
+            <a:off x="822960" y="457200"/>
+            <a:ext cx="10789920" cy="777240"/>
+          </a:xfrm>
+          <a:prstGeom prst="rect">
+            <a:avLst/>
+          </a:prstGeom>
+          <a:noFill/>
+        </p:spPr>
+        <p:txBody>
+          <a:bodyPr wrap="square">
+            <a:spAutoFit/>
+          </a:bodyPr>
+          <a:lstStyle/>
+          <a:p>
+            <a:r>
+              <a:rPr sz="3000" b="1">
+                <a:solidFill>
+                  <a:srgbClr val="0F203C"/>
+                </a:solidFill>
+              </a:rPr>
               <a:t>Casos de uso de alto riesgo</a:t>
             </a:r>
           </a:p>
@@ -4341,15 +4613,15 @@
       </p:sp>
       <p:graphicFrame>
         <p:nvGraphicFramePr>
-          <p:cNvPr id="3" name="Table 2"/>
+          <p:cNvPr id="4" name="Table 3"/>
           <p:cNvGraphicFramePr>
             <a:graphicFrameLocks noGrp="1"/>
           </p:cNvGraphicFramePr>
           <p:nvPr/>
         </p:nvGraphicFramePr>
         <p:xfrm>
-          <a:off x="365760" y="1554480"/>
-          <a:ext cx="8412480" cy="3474720"/>
+          <a:off x="548640" y="1554480"/>
+          <a:ext cx="11064240" cy="3474720"/>
         </p:xfrm>
         <a:graphic>
           <a:graphicData uri="http://schemas.openxmlformats.org/drawingml/2006/table">
@@ -4358,9 +4630,9 @@
                 <a:tableStyleId>{5C22544A-7EE6-4342-B048-85BDC9FD1C3A}</a:tableStyleId>
               </a:tblPr>
               <a:tblGrid>
-                <a:gridCol w="2804160"/>
-                <a:gridCol w="2804160"/>
-                <a:gridCol w="2804160"/>
+                <a:gridCol w="3688080"/>
+                <a:gridCol w="3688080"/>
+                <a:gridCol w="3688080"/>
               </a:tblGrid>
               <a:tr h="1158240">
                 <a:tc>
@@ -4369,7 +4641,7 @@
                     <a:lstStyle/>
                     <a:p>
                       <a:r>
-                        <a:rPr sz="1400" b="1"/>
+                        <a:rPr sz="1500" b="1"/>
                         <a:t>Caso de uso (riesgo alto)</a:t>
                       </a:r>
                     </a:p>
@@ -4386,7 +4658,7 @@
                     <a:lstStyle/>
                     <a:p>
                       <a:r>
-                        <a:rPr sz="1400" b="1"/>
+                        <a:rPr sz="1500" b="1"/>
                         <a:t>Descripción</a:t>
                       </a:r>
                     </a:p>
@@ -4403,7 +4675,7 @@
                     <a:lstStyle/>
                     <a:p>
                       <a:r>
-                        <a:rPr sz="1400" b="1"/>
+                        <a:rPr sz="1500" b="1"/>
                         <a:t>Quién lo cubre</a:t>
                       </a:r>
                     </a:p>
@@ -4422,7 +4694,7 @@
                     <a:lstStyle/>
                     <a:p>
                       <a:r>
-                        <a:rPr sz="1200"/>
+                        <a:rPr sz="1300"/>
                         <a:t>Cribado automático de candidaturas</a:t>
                       </a:r>
                     </a:p>
@@ -4439,7 +4711,7 @@
                     <a:lstStyle/>
                     <a:p>
                       <a:r>
-                        <a:rPr sz="1200"/>
+                        <a:rPr sz="1300"/>
                         <a:t>Sistema de apoyo a decisiones de contratación; alto impacto en personas y obligaciones de equidad y transparencia.</a:t>
                       </a:r>
                     </a:p>
@@ -4456,7 +4728,7 @@
                     <a:lstStyle/>
                     <a:p>
                       <a:r>
-                        <a:rPr sz="1200"/>
+                        <a:rPr sz="1300"/>
                         <a:t>Lucía Marín (60%), Yuki Tanaka (30%), Bruno Salgado (25%)</a:t>
                       </a:r>
                     </a:p>
@@ -4475,7 +4747,7 @@
                     <a:lstStyle/>
                     <a:p>
                       <a:r>
-                        <a:rPr sz="1200"/>
+                        <a:rPr sz="1300"/>
                         <a:t>Triaje clínico asistido</a:t>
                       </a:r>
                     </a:p>
@@ -4492,7 +4764,7 @@
                     <a:lstStyle/>
                     <a:p>
                       <a:r>
-                        <a:rPr sz="1200"/>
+                        <a:rPr sz="1300"/>
                         <a:t>Recomendación de prioridad en atención sanitaria; alto riesgo, requiere validación clínica y trazabilidad.</a:t>
                       </a:r>
                     </a:p>
@@ -4509,7 +4781,7 @@
                     <a:lstStyle/>
                     <a:p>
                       <a:r>
-                        <a:rPr sz="1200"/>
+                        <a:rPr sz="1300"/>
                         <a:t>Aisha Nassiri (70%), Yuki Tanaka (40%)</a:t>
                       </a:r>
                     </a:p>
@@ -4527,14 +4799,14 @@
       </p:graphicFrame>
       <p:sp>
         <p:nvSpPr>
-          <p:cNvPr id="4" name="TextBox 3"/>
+          <p:cNvPr id="5" name="TextBox 4"/>
           <p:cNvSpPr txBox="1"/>
           <p:nvPr/>
         </p:nvSpPr>
         <p:spPr>
           <a:xfrm>
-            <a:off x="365760" y="5303520"/>
-            <a:ext cx="8412480" cy="731520"/>
+            <a:off x="548640" y="5303520"/>
+            <a:ext cx="11064240" cy="640080"/>
           </a:xfrm>
           <a:prstGeom prst="rect">
             <a:avLst/>

</xml_diff>

<commit_message>
docs: switch report to 16:9 with column chart (#6)
- Widescreen 16:9 canvas (13.333x7.5in)
- NIST risk focus now uses a column/bar chart instead of a pie
- No logo (confidentiality); all data remains synthetic

Co-authored-by: Kiro Agent <244629292+kiro-agent@users.noreply.github.com>
</commit_message>
<xml_diff>
--- a/docs/Informe_Asignaciones.pptx
+++ b/docs/Informe_Asignaciones.pptx
@@ -10,7 +10,7 @@
     <p:sldId id="258" r:id="rId9"/>
     <p:sldId id="259" r:id="rId10"/>
   </p:sldIdLst>
-  <p:sldSz cx="9144000" cy="6858000" type="screen4x3"/>
+  <p:sldSz cx="12192000" cy="6858000" type="screen4x3"/>
   <p:notesSz cx="6858000" cy="9144000"/>
   <p:defaultTextStyle>
     <a:defPPr>
@@ -112,6 +112,7 @@
 
 <file path=ppt/charts/chart1.xml><?xml version="1.0" encoding="utf-8"?>
 <c:chartSpace xmlns:c="http://schemas.openxmlformats.org/drawingml/2006/chart" xmlns:a="http://schemas.openxmlformats.org/drawingml/2006/main" xmlns:r="http://schemas.openxmlformats.org/officeDocument/2006/relationships">
+  <c:date1904 val="0"/>
   <c:chart>
     <c:title>
       <c:tx>
@@ -120,7 +121,7 @@
           <a:lstStyle/>
           <a:p>
             <a:r>
-              <a:t>Capacidad del equipo por nivel de riesgo</a:t>
+              <a:t>Capacidad del equipo por nivel de riesgo (pts)</a:t>
             </a:r>
           </a:p>
         </c:rich>
@@ -130,8 +131,9 @@
     </c:title>
     <c:autoTitleDeleted val="0"/>
     <c:plotArea>
-      <c:pieChart>
-        <c:varyColors val="1"/>
+      <c:barChart>
+        <c:barDir val="col"/>
+        <c:grouping val="clustered"/>
         <c:ser>
           <c:idx val="0"/>
           <c:order val="0"/>
@@ -182,9 +184,39 @@
             </c:numRef>
           </c:val>
         </c:ser>
-      </c:pieChart>
+        <c:axId val="-2068027336"/>
+        <c:axId val="-2113994440"/>
+      </c:barChart>
+      <c:catAx>
+        <c:axId val="-2068027336"/>
+        <c:scaling>
+          <c:orientation val="minMax"/>
+        </c:scaling>
+        <c:delete val="0"/>
+        <c:axPos val="b"/>
+        <c:majorTickMark val="out"/>
+        <c:minorTickMark val="none"/>
+        <c:tickLblPos val="nextTo"/>
+        <c:crossAx val="-2113994440"/>
+        <c:crosses val="autoZero"/>
+        <c:auto val="1"/>
+        <c:lblAlgn val="ctr"/>
+        <c:lblOffset val="100"/>
+        <c:noMultiLvlLbl val="0"/>
+      </c:catAx>
+      <c:valAx>
+        <c:axId val="-2113994440"/>
+        <c:scaling/>
+        <c:delete val="0"/>
+        <c:axPos val="l"/>
+        <c:majorGridlines/>
+        <c:majorTickMark val="out"/>
+        <c:minorTickMark val="none"/>
+        <c:tickLblPos val="nextTo"/>
+        <c:crossAx val="-2068027336"/>
+        <c:crosses val="autoZero"/>
+      </c:valAx>
     </c:plotArea>
-    <c:legend/>
     <c:dispBlanksAs val="gap"/>
   </c:chart>
   <c:txPr>
@@ -3186,42 +3218,78 @@
       <p:grpSpPr/>
       <p:sp>
         <p:nvSpPr>
-          <p:cNvPr id="2" name="Title 1"/>
-          <p:cNvSpPr>
-            <a:spLocks noGrp="1"/>
-          </p:cNvSpPr>
-          <p:nvPr>
-            <p:ph type="ctrTitle"/>
-          </p:nvPr>
-        </p:nvSpPr>
-        <p:spPr/>
-        <p:txBody>
-          <a:bodyPr/>
-          <a:lstStyle/>
-          <a:p>
-            <a:r>
+          <p:cNvPr id="2" name="Rectangle 1"/>
+          <p:cNvSpPr/>
+          <p:nvPr/>
+        </p:nvSpPr>
+        <p:spPr>
+          <a:xfrm>
+            <a:off x="731520" y="2148840"/>
+            <a:ext cx="2926080" cy="91440"/>
+          </a:xfrm>
+          <a:prstGeom prst="rect">
+            <a:avLst/>
+          </a:prstGeom>
+          <a:solidFill>
+            <a:srgbClr val="2563EB"/>
+          </a:solidFill>
+          <a:ln>
+            <a:solidFill>
+              <a:srgbClr val="2563EB"/>
+            </a:solidFill>
+          </a:ln>
+        </p:spPr>
+        <p:style>
+          <a:lnRef idx="1">
+            <a:schemeClr val="accent1"/>
+          </a:lnRef>
+          <a:fillRef idx="3">
+            <a:schemeClr val="accent1"/>
+          </a:fillRef>
+          <a:effectRef idx="2">
+            <a:schemeClr val="accent1"/>
+          </a:effectRef>
+          <a:fontRef idx="minor">
+            <a:schemeClr val="lt1"/>
+          </a:fontRef>
+        </p:style>
+        <p:txBody>
+          <a:bodyPr rtlCol="0" anchor="ctr"/>
+          <a:lstStyle/>
+          <a:p>
+            <a:pPr algn="ctr"/>
+          </a:p>
+        </p:txBody>
+      </p:sp>
+      <p:sp>
+        <p:nvSpPr>
+          <p:cNvPr id="3" name="TextBox 2"/>
+          <p:cNvSpPr txBox="1"/>
+          <p:nvPr/>
+        </p:nvSpPr>
+        <p:spPr>
+          <a:xfrm>
+            <a:off x="731520" y="2377440"/>
+            <a:ext cx="10698480" cy="1371600"/>
+          </a:xfrm>
+          <a:prstGeom prst="rect">
+            <a:avLst/>
+          </a:prstGeom>
+          <a:noFill/>
+        </p:spPr>
+        <p:txBody>
+          <a:bodyPr wrap="square">
+            <a:spAutoFit/>
+          </a:bodyPr>
+          <a:lstStyle/>
+          <a:p>
+            <a:r>
+              <a:rPr sz="4200" b="1">
+                <a:solidFill>
+                  <a:srgbClr val="0F203C"/>
+                </a:solidFill>
+              </a:rPr>
               <a:t>Informe de Asignaciones del Equipo de IA</a:t>
-            </a:r>
-          </a:p>
-        </p:txBody>
-      </p:sp>
-      <p:sp>
-        <p:nvSpPr>
-          <p:cNvPr id="3" name="Subtitle 2"/>
-          <p:cNvSpPr>
-            <a:spLocks noGrp="1"/>
-          </p:cNvSpPr>
-          <p:nvPr>
-            <p:ph type="subTitle" idx="1"/>
-          </p:nvPr>
-        </p:nvSpPr>
-        <p:spPr/>
-        <p:txBody>
-          <a:bodyPr/>
-          <a:lstStyle/>
-          <a:p>
-            <a:r>
-              <a:t>Datos sintéticos de demostración</a:t>
             </a:r>
           </a:p>
         </p:txBody>
@@ -3234,7 +3302,40 @@
         </p:nvSpPr>
         <p:spPr>
           <a:xfrm>
-            <a:off x="822960" y="5852160"/>
+            <a:off x="731520" y="3794760"/>
+            <a:ext cx="10698480" cy="640080"/>
+          </a:xfrm>
+          <a:prstGeom prst="rect">
+            <a:avLst/>
+          </a:prstGeom>
+          <a:noFill/>
+        </p:spPr>
+        <p:txBody>
+          <a:bodyPr wrap="square">
+            <a:spAutoFit/>
+          </a:bodyPr>
+          <a:lstStyle/>
+          <a:p>
+            <a:r>
+              <a:rPr sz="2200">
+                <a:solidFill>
+                  <a:srgbClr val="2563EB"/>
+                </a:solidFill>
+              </a:rPr>
+              <a:t>Datos sintéticos de demostración</a:t>
+            </a:r>
+          </a:p>
+        </p:txBody>
+      </p:sp>
+      <p:sp>
+        <p:nvSpPr>
+          <p:cNvPr id="5" name="TextBox 4"/>
+          <p:cNvSpPr txBox="1"/>
+          <p:nvPr/>
+        </p:nvSpPr>
+        <p:spPr>
+          <a:xfrm>
+            <a:off x="731520" y="4572000"/>
             <a:ext cx="7315200" cy="457200"/>
           </a:xfrm>
           <a:prstGeom prst="rect">
@@ -3251,7 +3352,7 @@
             <a:r>
               <a:rPr sz="1600" i="1">
                 <a:solidFill>
-                  <a:srgbClr val="2563EB"/>
+                  <a:srgbClr val="5A5A5A"/>
                 </a:solidFill>
               </a:rPr>
               <a:t>22 de septiembre de 2026</a:t>
@@ -3261,14 +3362,14 @@
       </p:sp>
       <p:sp>
         <p:nvSpPr>
-          <p:cNvPr id="5" name="TextBox 4"/>
+          <p:cNvPr id="6" name="TextBox 5"/>
           <p:cNvSpPr txBox="1"/>
           <p:nvPr/>
         </p:nvSpPr>
         <p:spPr>
           <a:xfrm>
-            <a:off x="822960" y="6263640"/>
-            <a:ext cx="7772400" cy="365760"/>
+            <a:off x="731520" y="6172200"/>
+            <a:ext cx="10698480" cy="365760"/>
           </a:xfrm>
           <a:prstGeom prst="rect">
             <a:avLst/>
@@ -3284,7 +3385,7 @@
             <a:r>
               <a:rPr sz="1100">
                 <a:solidFill>
-                  <a:srgbClr val="787878"/>
+                  <a:srgbClr val="8C8C8C"/>
                 </a:solidFill>
               </a:rPr>
               <a:t>Todos los nombres, casos de uso y cifras son ficticios.</a:t>
@@ -3312,20 +3413,77 @@
       <p:grpSpPr/>
       <p:sp>
         <p:nvSpPr>
-          <p:cNvPr id="2" name="Title 1"/>
-          <p:cNvSpPr>
-            <a:spLocks noGrp="1"/>
-          </p:cNvSpPr>
-          <p:nvPr>
-            <p:ph type="title"/>
-          </p:nvPr>
-        </p:nvSpPr>
-        <p:spPr/>
-        <p:txBody>
-          <a:bodyPr/>
-          <a:lstStyle/>
-          <a:p>
-            <a:r>
+          <p:cNvPr id="2" name="Rectangle 1"/>
+          <p:cNvSpPr/>
+          <p:nvPr/>
+        </p:nvSpPr>
+        <p:spPr>
+          <a:xfrm>
+            <a:off x="548640" y="502920"/>
+            <a:ext cx="128016" cy="658368"/>
+          </a:xfrm>
+          <a:prstGeom prst="rect">
+            <a:avLst/>
+          </a:prstGeom>
+          <a:solidFill>
+            <a:srgbClr val="2563EB"/>
+          </a:solidFill>
+          <a:ln>
+            <a:solidFill>
+              <a:srgbClr val="2563EB"/>
+            </a:solidFill>
+          </a:ln>
+        </p:spPr>
+        <p:style>
+          <a:lnRef idx="1">
+            <a:schemeClr val="accent1"/>
+          </a:lnRef>
+          <a:fillRef idx="3">
+            <a:schemeClr val="accent1"/>
+          </a:fillRef>
+          <a:effectRef idx="2">
+            <a:schemeClr val="accent1"/>
+          </a:effectRef>
+          <a:fontRef idx="minor">
+            <a:schemeClr val="lt1"/>
+          </a:fontRef>
+        </p:style>
+        <p:txBody>
+          <a:bodyPr rtlCol="0" anchor="ctr"/>
+          <a:lstStyle/>
+          <a:p>
+            <a:pPr algn="ctr"/>
+          </a:p>
+        </p:txBody>
+      </p:sp>
+      <p:sp>
+        <p:nvSpPr>
+          <p:cNvPr id="3" name="TextBox 2"/>
+          <p:cNvSpPr txBox="1"/>
+          <p:nvPr/>
+        </p:nvSpPr>
+        <p:spPr>
+          <a:xfrm>
+            <a:off x="822960" y="457200"/>
+            <a:ext cx="10789920" cy="777240"/>
+          </a:xfrm>
+          <a:prstGeom prst="rect">
+            <a:avLst/>
+          </a:prstGeom>
+          <a:noFill/>
+        </p:spPr>
+        <p:txBody>
+          <a:bodyPr wrap="square">
+            <a:spAutoFit/>
+          </a:bodyPr>
+          <a:lstStyle/>
+          <a:p>
+            <a:r>
+              <a:rPr sz="3000" b="1">
+                <a:solidFill>
+                  <a:srgbClr val="0F203C"/>
+                </a:solidFill>
+              </a:rPr>
               <a:t>Carga por persona</a:t>
             </a:r>
           </a:p>
@@ -3333,15 +3491,15 @@
       </p:sp>
       <p:graphicFrame>
         <p:nvGraphicFramePr>
-          <p:cNvPr id="3" name="Table 2"/>
+          <p:cNvPr id="4" name="Table 3"/>
           <p:cNvGraphicFramePr>
             <a:graphicFrameLocks noGrp="1"/>
           </p:cNvGraphicFramePr>
           <p:nvPr/>
         </p:nvGraphicFramePr>
         <p:xfrm>
-          <a:off x="457200" y="1554480"/>
-          <a:ext cx="8229600" cy="4206240"/>
+          <a:off x="548640" y="1554480"/>
+          <a:ext cx="11064240" cy="4114800"/>
         </p:xfrm>
         <a:graphic>
           <a:graphicData uri="http://schemas.openxmlformats.org/drawingml/2006/table">
@@ -3350,19 +3508,19 @@
                 <a:tableStyleId>{5C22544A-7EE6-4342-B048-85BDC9FD1C3A}</a:tableStyleId>
               </a:tblPr>
               <a:tblGrid>
-                <a:gridCol w="2057400"/>
-                <a:gridCol w="2057400"/>
-                <a:gridCol w="2057400"/>
-                <a:gridCol w="2057400"/>
+                <a:gridCol w="2766060"/>
+                <a:gridCol w="2766060"/>
+                <a:gridCol w="2766060"/>
+                <a:gridCol w="2766060"/>
               </a:tblGrid>
-              <a:tr h="600891">
+              <a:tr h="587828">
                 <a:tc>
                   <a:txBody>
                     <a:bodyPr wrap="square"/>
                     <a:lstStyle/>
                     <a:p>
                       <a:r>
-                        <a:rPr sz="1500" b="1"/>
+                        <a:rPr sz="1600" b="1"/>
                         <a:t>Nombre</a:t>
                       </a:r>
                     </a:p>
@@ -3379,7 +3537,7 @@
                     <a:lstStyle/>
                     <a:p>
                       <a:r>
-                        <a:rPr sz="1500" b="1"/>
+                        <a:rPr sz="1600" b="1"/>
                         <a:t>Rol</a:t>
                       </a:r>
                     </a:p>
@@ -3396,7 +3554,7 @@
                     <a:lstStyle/>
                     <a:p>
                       <a:r>
-                        <a:rPr sz="1500" b="1"/>
+                        <a:rPr sz="1600" b="1"/>
                         <a:t>% dedicación total</a:t>
                       </a:r>
                     </a:p>
@@ -3413,7 +3571,7 @@
                     <a:lstStyle/>
                     <a:p>
                       <a:r>
-                        <a:rPr sz="1500" b="1"/>
+                        <a:rPr sz="1600" b="1"/>
                         <a:t>Estado (semáforo)</a:t>
                       </a:r>
                     </a:p>
@@ -3425,14 +3583,14 @@
                   </a:tcPr>
                 </a:tc>
               </a:tr>
-              <a:tr h="600891">
+              <a:tr h="587828">
                 <a:tc>
                   <a:txBody>
                     <a:bodyPr wrap="square"/>
                     <a:lstStyle/>
                     <a:p>
                       <a:r>
-                        <a:rPr sz="1400"/>
+                        <a:rPr sz="1500"/>
                         <a:t>Lucía Marín</a:t>
                       </a:r>
                     </a:p>
@@ -3449,7 +3607,7 @@
                     <a:lstStyle/>
                     <a:p>
                       <a:r>
-                        <a:rPr sz="1400"/>
+                        <a:rPr sz="1500"/>
                         <a:t>ML Engineer</a:t>
                       </a:r>
                     </a:p>
@@ -3467,7 +3625,7 @@
                     <a:p>
                       <a:pPr algn="ctr"/>
                       <a:r>
-                        <a:rPr sz="1400"/>
+                        <a:rPr sz="1500"/>
                         <a:t>90%</a:t>
                       </a:r>
                     </a:p>
@@ -3485,7 +3643,7 @@
                     <a:p>
                       <a:pPr algn="ctr"/>
                       <a:r>
-                        <a:rPr sz="1400" b="1">
+                        <a:rPr sz="1500" b="1">
                           <a:solidFill>
                             <a:srgbClr val="FFFFFF"/>
                           </a:solidFill>
@@ -3501,14 +3659,14 @@
                   </a:tcPr>
                 </a:tc>
               </a:tr>
-              <a:tr h="600891">
+              <a:tr h="587828">
                 <a:tc>
                   <a:txBody>
                     <a:bodyPr wrap="square"/>
                     <a:lstStyle/>
                     <a:p>
                       <a:r>
-                        <a:rPr sz="1400"/>
+                        <a:rPr sz="1500"/>
                         <a:t>Diego Ferrán</a:t>
                       </a:r>
                     </a:p>
@@ -3525,7 +3683,7 @@
                     <a:lstStyle/>
                     <a:p>
                       <a:r>
-                        <a:rPr sz="1400"/>
+                        <a:rPr sz="1500"/>
                         <a:t>Data Scientist</a:t>
                       </a:r>
                     </a:p>
@@ -3543,7 +3701,7 @@
                     <a:p>
                       <a:pPr algn="ctr"/>
                       <a:r>
-                        <a:rPr sz="1400"/>
+                        <a:rPr sz="1500"/>
                         <a:t>90%</a:t>
                       </a:r>
                     </a:p>
@@ -3561,7 +3719,7 @@
                     <a:p>
                       <a:pPr algn="ctr"/>
                       <a:r>
-                        <a:rPr sz="1400" b="1">
+                        <a:rPr sz="1500" b="1">
                           <a:solidFill>
                             <a:srgbClr val="FFFFFF"/>
                           </a:solidFill>
@@ -3577,14 +3735,14 @@
                   </a:tcPr>
                 </a:tc>
               </a:tr>
-              <a:tr h="600891">
+              <a:tr h="587828">
                 <a:tc>
                   <a:txBody>
                     <a:bodyPr wrap="square"/>
                     <a:lstStyle/>
                     <a:p>
                       <a:r>
-                        <a:rPr sz="1400"/>
+                        <a:rPr sz="1500"/>
                         <a:t>Aisha Nassiri</a:t>
                       </a:r>
                     </a:p>
@@ -3601,7 +3759,7 @@
                     <a:lstStyle/>
                     <a:p>
                       <a:r>
-                        <a:rPr sz="1400"/>
+                        <a:rPr sz="1500"/>
                         <a:t>MLOps Engineer</a:t>
                       </a:r>
                     </a:p>
@@ -3619,7 +3777,7 @@
                     <a:p>
                       <a:pPr algn="ctr"/>
                       <a:r>
-                        <a:rPr sz="1400"/>
+                        <a:rPr sz="1500"/>
                         <a:t>115%</a:t>
                       </a:r>
                     </a:p>
@@ -3637,7 +3795,7 @@
                     <a:p>
                       <a:pPr algn="ctr"/>
                       <a:r>
-                        <a:rPr sz="1400" b="1">
+                        <a:rPr sz="1500" b="1">
                           <a:solidFill>
                             <a:srgbClr val="FFFFFF"/>
                           </a:solidFill>
@@ -3653,14 +3811,14 @@
                   </a:tcPr>
                 </a:tc>
               </a:tr>
-              <a:tr h="600891">
+              <a:tr h="587828">
                 <a:tc>
                   <a:txBody>
                     <a:bodyPr wrap="square"/>
                     <a:lstStyle/>
                     <a:p>
                       <a:r>
-                        <a:rPr sz="1400"/>
+                        <a:rPr sz="1500"/>
                         <a:t>Bruno Salgado</a:t>
                       </a:r>
                     </a:p>
@@ -3677,7 +3835,7 @@
                     <a:lstStyle/>
                     <a:p>
                       <a:r>
-                        <a:rPr sz="1400"/>
+                        <a:rPr sz="1500"/>
                         <a:t>AI Product Manager</a:t>
                       </a:r>
                     </a:p>
@@ -3695,7 +3853,7 @@
                     <a:p>
                       <a:pPr algn="ctr"/>
                       <a:r>
-                        <a:rPr sz="1400"/>
+                        <a:rPr sz="1500"/>
                         <a:t>50%</a:t>
                       </a:r>
                     </a:p>
@@ -3713,7 +3871,7 @@
                     <a:p>
                       <a:pPr algn="ctr"/>
                       <a:r>
-                        <a:rPr sz="1400" b="1">
+                        <a:rPr sz="1500" b="1">
                           <a:solidFill>
                             <a:srgbClr val="FFFFFF"/>
                           </a:solidFill>
@@ -3729,14 +3887,14 @@
                   </a:tcPr>
                 </a:tc>
               </a:tr>
-              <a:tr h="600891">
+              <a:tr h="587828">
                 <a:tc>
                   <a:txBody>
                     <a:bodyPr wrap="square"/>
                     <a:lstStyle/>
                     <a:p>
                       <a:r>
-                        <a:rPr sz="1400"/>
+                        <a:rPr sz="1500"/>
                         <a:t>Yuki Tanaka</a:t>
                       </a:r>
                     </a:p>
@@ -3753,7 +3911,7 @@
                     <a:lstStyle/>
                     <a:p>
                       <a:r>
-                        <a:rPr sz="1400"/>
+                        <a:rPr sz="1500"/>
                         <a:t>Responsible AI Lead</a:t>
                       </a:r>
                     </a:p>
@@ -3771,7 +3929,7 @@
                     <a:p>
                       <a:pPr algn="ctr"/>
                       <a:r>
-                        <a:rPr sz="1400"/>
+                        <a:rPr sz="1500"/>
                         <a:t>70%</a:t>
                       </a:r>
                     </a:p>
@@ -3789,7 +3947,7 @@
                     <a:p>
                       <a:pPr algn="ctr"/>
                       <a:r>
-                        <a:rPr sz="1400" b="1">
+                        <a:rPr sz="1500" b="1">
                           <a:solidFill>
                             <a:srgbClr val="FFFFFF"/>
                           </a:solidFill>
@@ -3805,14 +3963,14 @@
                   </a:tcPr>
                 </a:tc>
               </a:tr>
-              <a:tr h="600894">
+              <a:tr h="587832">
                 <a:tc>
                   <a:txBody>
                     <a:bodyPr wrap="square"/>
                     <a:lstStyle/>
                     <a:p>
                       <a:r>
-                        <a:rPr sz="1400"/>
+                        <a:rPr sz="1500"/>
                         <a:t>Elena Rossi</a:t>
                       </a:r>
                     </a:p>
@@ -3829,7 +3987,7 @@
                     <a:lstStyle/>
                     <a:p>
                       <a:r>
-                        <a:rPr sz="1400"/>
+                        <a:rPr sz="1500"/>
                         <a:t>Prompt Engineer</a:t>
                       </a:r>
                     </a:p>
@@ -3847,7 +4005,7 @@
                     <a:p>
                       <a:pPr algn="ctr"/>
                       <a:r>
-                        <a:rPr sz="1400"/>
+                        <a:rPr sz="1500"/>
                         <a:t>55%</a:t>
                       </a:r>
                     </a:p>
@@ -3865,7 +4023,7 @@
                     <a:p>
                       <a:pPr algn="ctr"/>
                       <a:r>
-                        <a:rPr sz="1400" b="1">
+                        <a:rPr sz="1500" b="1">
                           <a:solidFill>
                             <a:srgbClr val="FFFFFF"/>
                           </a:solidFill>
@@ -3887,14 +4045,14 @@
       </p:graphicFrame>
       <p:sp>
         <p:nvSpPr>
-          <p:cNvPr id="4" name="TextBox 3"/>
+          <p:cNvPr id="5" name="TextBox 4"/>
           <p:cNvSpPr txBox="1"/>
           <p:nvPr/>
         </p:nvSpPr>
         <p:spPr>
           <a:xfrm>
-            <a:off x="457200" y="5943600"/>
-            <a:ext cx="8229600" cy="548640"/>
+            <a:off x="548640" y="5943600"/>
+            <a:ext cx="11064240" cy="457200"/>
           </a:xfrm>
           <a:prstGeom prst="rect">
             <a:avLst/>
@@ -3938,20 +4096,77 @@
       <p:grpSpPr/>
       <p:sp>
         <p:nvSpPr>
-          <p:cNvPr id="2" name="Title 1"/>
-          <p:cNvSpPr>
-            <a:spLocks noGrp="1"/>
-          </p:cNvSpPr>
-          <p:nvPr>
-            <p:ph type="title"/>
-          </p:nvPr>
-        </p:nvSpPr>
-        <p:spPr/>
-        <p:txBody>
-          <a:bodyPr/>
-          <a:lstStyle/>
-          <a:p>
-            <a:r>
+          <p:cNvPr id="2" name="Rectangle 1"/>
+          <p:cNvSpPr/>
+          <p:nvPr/>
+        </p:nvSpPr>
+        <p:spPr>
+          <a:xfrm>
+            <a:off x="548640" y="502920"/>
+            <a:ext cx="128016" cy="658368"/>
+          </a:xfrm>
+          <a:prstGeom prst="rect">
+            <a:avLst/>
+          </a:prstGeom>
+          <a:solidFill>
+            <a:srgbClr val="2563EB"/>
+          </a:solidFill>
+          <a:ln>
+            <a:solidFill>
+              <a:srgbClr val="2563EB"/>
+            </a:solidFill>
+          </a:ln>
+        </p:spPr>
+        <p:style>
+          <a:lnRef idx="1">
+            <a:schemeClr val="accent1"/>
+          </a:lnRef>
+          <a:fillRef idx="3">
+            <a:schemeClr val="accent1"/>
+          </a:fillRef>
+          <a:effectRef idx="2">
+            <a:schemeClr val="accent1"/>
+          </a:effectRef>
+          <a:fontRef idx="minor">
+            <a:schemeClr val="lt1"/>
+          </a:fontRef>
+        </p:style>
+        <p:txBody>
+          <a:bodyPr rtlCol="0" anchor="ctr"/>
+          <a:lstStyle/>
+          <a:p>
+            <a:pPr algn="ctr"/>
+          </a:p>
+        </p:txBody>
+      </p:sp>
+      <p:sp>
+        <p:nvSpPr>
+          <p:cNvPr id="3" name="TextBox 2"/>
+          <p:cNvSpPr txBox="1"/>
+          <p:nvPr/>
+        </p:nvSpPr>
+        <p:spPr>
+          <a:xfrm>
+            <a:off x="822960" y="457200"/>
+            <a:ext cx="10789920" cy="777240"/>
+          </a:xfrm>
+          <a:prstGeom prst="rect">
+            <a:avLst/>
+          </a:prstGeom>
+          <a:noFill/>
+        </p:spPr>
+        <p:txBody>
+          <a:bodyPr wrap="square">
+            <a:spAutoFit/>
+          </a:bodyPr>
+          <a:lstStyle/>
+          <a:p>
+            <a:r>
+              <a:rPr sz="3000" b="1">
+                <a:solidFill>
+                  <a:srgbClr val="0F203C"/>
+                </a:solidFill>
+              </a:rPr>
               <a:t>Foco por riesgo (NIST)</a:t>
             </a:r>
           </a:p>
@@ -3959,15 +4174,15 @@
       </p:sp>
       <p:graphicFrame>
         <p:nvGraphicFramePr>
-          <p:cNvPr id="3" name="Table 2"/>
+          <p:cNvPr id="4" name="Table 3"/>
           <p:cNvGraphicFramePr>
             <a:graphicFrameLocks noGrp="1"/>
           </p:cNvGraphicFramePr>
           <p:nvPr/>
         </p:nvGraphicFramePr>
         <p:xfrm>
-          <a:off x="457200" y="1645920"/>
-          <a:ext cx="4023360" cy="2926080"/>
+          <a:off x="548640" y="1737360"/>
+          <a:ext cx="4937760" cy="2743200"/>
         </p:xfrm>
         <a:graphic>
           <a:graphicData uri="http://schemas.openxmlformats.org/drawingml/2006/table">
@@ -3976,18 +4191,18 @@
                 <a:tableStyleId>{5C22544A-7EE6-4342-B048-85BDC9FD1C3A}</a:tableStyleId>
               </a:tblPr>
               <a:tblGrid>
-                <a:gridCol w="1341120"/>
-                <a:gridCol w="1341120"/>
-                <a:gridCol w="1341120"/>
+                <a:gridCol w="1645920"/>
+                <a:gridCol w="1645920"/>
+                <a:gridCol w="1645920"/>
               </a:tblGrid>
-              <a:tr h="585216">
+              <a:tr h="548640">
                 <a:tc>
                   <a:txBody>
                     <a:bodyPr wrap="square"/>
                     <a:lstStyle/>
                     <a:p>
                       <a:r>
-                        <a:rPr sz="1400" b="1"/>
+                        <a:rPr sz="1500" b="1"/>
                         <a:t>Nivel de riesgo</a:t>
                       </a:r>
                     </a:p>
@@ -4004,7 +4219,7 @@
                     <a:lstStyle/>
                     <a:p>
                       <a:r>
-                        <a:rPr sz="1400" b="1"/>
+                        <a:rPr sz="1500" b="1"/>
                         <a:t>Capacidad (pts)</a:t>
                       </a:r>
                     </a:p>
@@ -4021,7 +4236,7 @@
                     <a:lstStyle/>
                     <a:p>
                       <a:r>
-                        <a:rPr sz="1400" b="1"/>
+                        <a:rPr sz="1500" b="1"/>
                         <a:t>% del total</a:t>
                       </a:r>
                     </a:p>
@@ -4033,14 +4248,14 @@
                   </a:tcPr>
                 </a:tc>
               </a:tr>
-              <a:tr h="585216">
+              <a:tr h="548640">
                 <a:tc>
                   <a:txBody>
                     <a:bodyPr wrap="square"/>
                     <a:lstStyle/>
                     <a:p>
                       <a:r>
-                        <a:rPr sz="1300"/>
+                        <a:rPr sz="1400"/>
                         <a:t>Bajo</a:t>
                       </a:r>
                     </a:p>
@@ -4057,7 +4272,7 @@
                     <a:lstStyle/>
                     <a:p>
                       <a:r>
-                        <a:rPr sz="1300"/>
+                        <a:rPr sz="1400"/>
                         <a:t>85</a:t>
                       </a:r>
                     </a:p>
@@ -4074,7 +4289,7 @@
                     <a:lstStyle/>
                     <a:p>
                       <a:r>
-                        <a:rPr sz="1300"/>
+                        <a:rPr sz="1400"/>
                         <a:t>18%</a:t>
                       </a:r>
                     </a:p>
@@ -4086,14 +4301,14 @@
                   </a:tcPr>
                 </a:tc>
               </a:tr>
-              <a:tr h="585216">
+              <a:tr h="548640">
                 <a:tc>
                   <a:txBody>
                     <a:bodyPr wrap="square"/>
                     <a:lstStyle/>
                     <a:p>
                       <a:r>
-                        <a:rPr sz="1300"/>
+                        <a:rPr sz="1400"/>
                         <a:t>Medio</a:t>
                       </a:r>
                     </a:p>
@@ -4110,7 +4325,7 @@
                     <a:lstStyle/>
                     <a:p>
                       <a:r>
-                        <a:rPr sz="1300"/>
+                        <a:rPr sz="1400"/>
                         <a:t>160</a:t>
                       </a:r>
                     </a:p>
@@ -4127,7 +4342,7 @@
                     <a:lstStyle/>
                     <a:p>
                       <a:r>
-                        <a:rPr sz="1300"/>
+                        <a:rPr sz="1400"/>
                         <a:t>34%</a:t>
                       </a:r>
                     </a:p>
@@ -4139,14 +4354,14 @@
                   </a:tcPr>
                 </a:tc>
               </a:tr>
-              <a:tr h="585216">
+              <a:tr h="548640">
                 <a:tc>
                   <a:txBody>
                     <a:bodyPr wrap="square"/>
                     <a:lstStyle/>
                     <a:p>
                       <a:r>
-                        <a:rPr sz="1300"/>
+                        <a:rPr sz="1400"/>
                         <a:t>Alto</a:t>
                       </a:r>
                     </a:p>
@@ -4163,7 +4378,7 @@
                     <a:lstStyle/>
                     <a:p>
                       <a:r>
-                        <a:rPr sz="1300"/>
+                        <a:rPr sz="1400"/>
                         <a:t>225</a:t>
                       </a:r>
                     </a:p>
@@ -4180,7 +4395,7 @@
                     <a:lstStyle/>
                     <a:p>
                       <a:r>
-                        <a:rPr sz="1300"/>
+                        <a:rPr sz="1400"/>
                         <a:t>48%</a:t>
                       </a:r>
                     </a:p>
@@ -4192,14 +4407,14 @@
                   </a:tcPr>
                 </a:tc>
               </a:tr>
-              <a:tr h="585216">
+              <a:tr h="548640">
                 <a:tc>
                   <a:txBody>
                     <a:bodyPr wrap="square"/>
                     <a:lstStyle/>
                     <a:p>
                       <a:r>
-                        <a:rPr sz="1300"/>
+                        <a:rPr sz="1400"/>
                         <a:t>Total</a:t>
                       </a:r>
                     </a:p>
@@ -4216,7 +4431,7 @@
                     <a:lstStyle/>
                     <a:p>
                       <a:r>
-                        <a:rPr sz="1300"/>
+                        <a:rPr sz="1400"/>
                         <a:t>470</a:t>
                       </a:r>
                     </a:p>
@@ -4233,7 +4448,7 @@
                     <a:lstStyle/>
                     <a:p>
                       <a:r>
-                        <a:rPr sz="1300"/>
+                        <a:rPr sz="1400"/>
                         <a:t>100%</a:t>
                       </a:r>
                     </a:p>
@@ -4251,15 +4466,15 @@
       </p:graphicFrame>
       <p:graphicFrame>
         <p:nvGraphicFramePr>
-          <p:cNvPr id="4" name="Chart 3"/>
+          <p:cNvPr id="5" name="Chart 4"/>
           <p:cNvGraphicFramePr>
             <a:graphicFrameLocks noGrp="1"/>
           </p:cNvGraphicFramePr>
           <p:nvPr/>
         </p:nvGraphicFramePr>
         <p:xfrm>
-          <a:off x="4663440" y="1371600"/>
-          <a:ext cx="4023360" cy="3931920"/>
+          <a:off x="5943600" y="1463040"/>
+          <a:ext cx="5669280" cy="4114800"/>
         </p:xfrm>
         <a:graphic>
           <a:graphicData uri="http://schemas.openxmlformats.org/drawingml/2006/chart">
@@ -4269,14 +4484,14 @@
       </p:graphicFrame>
       <p:sp>
         <p:nvSpPr>
-          <p:cNvPr id="5" name="TextBox 4"/>
+          <p:cNvPr id="6" name="TextBox 5"/>
           <p:cNvSpPr txBox="1"/>
           <p:nvPr/>
         </p:nvSpPr>
         <p:spPr>
           <a:xfrm>
-            <a:off x="457200" y="4754880"/>
-            <a:ext cx="4023360" cy="1097280"/>
+            <a:off x="548640" y="4754880"/>
+            <a:ext cx="4937760" cy="1188720"/>
           </a:xfrm>
           <a:prstGeom prst="rect">
             <a:avLst/>
@@ -4320,20 +4535,77 @@
       <p:grpSpPr/>
       <p:sp>
         <p:nvSpPr>
-          <p:cNvPr id="2" name="Title 1"/>
-          <p:cNvSpPr>
-            <a:spLocks noGrp="1"/>
-          </p:cNvSpPr>
-          <p:nvPr>
-            <p:ph type="title"/>
-          </p:nvPr>
-        </p:nvSpPr>
-        <p:spPr/>
-        <p:txBody>
-          <a:bodyPr/>
-          <a:lstStyle/>
-          <a:p>
-            <a:r>
+          <p:cNvPr id="2" name="Rectangle 1"/>
+          <p:cNvSpPr/>
+          <p:nvPr/>
+        </p:nvSpPr>
+        <p:spPr>
+          <a:xfrm>
+            <a:off x="548640" y="502920"/>
+            <a:ext cx="128016" cy="658368"/>
+          </a:xfrm>
+          <a:prstGeom prst="rect">
+            <a:avLst/>
+          </a:prstGeom>
+          <a:solidFill>
+            <a:srgbClr val="2563EB"/>
+          </a:solidFill>
+          <a:ln>
+            <a:solidFill>
+              <a:srgbClr val="2563EB"/>
+            </a:solidFill>
+          </a:ln>
+        </p:spPr>
+        <p:style>
+          <a:lnRef idx="1">
+            <a:schemeClr val="accent1"/>
+          </a:lnRef>
+          <a:fillRef idx="3">
+            <a:schemeClr val="accent1"/>
+          </a:fillRef>
+          <a:effectRef idx="2">
+            <a:schemeClr val="accent1"/>
+          </a:effectRef>
+          <a:fontRef idx="minor">
+            <a:schemeClr val="lt1"/>
+          </a:fontRef>
+        </p:style>
+        <p:txBody>
+          <a:bodyPr rtlCol="0" anchor="ctr"/>
+          <a:lstStyle/>
+          <a:p>
+            <a:pPr algn="ctr"/>
+          </a:p>
+        </p:txBody>
+      </p:sp>
+      <p:sp>
+        <p:nvSpPr>
+          <p:cNvPr id="3" name="TextBox 2"/>
+          <p:cNvSpPr txBox="1"/>
+          <p:nvPr/>
+        </p:nvSpPr>
+        <p:spPr>
+          <a:xfrm>
+            <a:off x="822960" y="457200"/>
+            <a:ext cx="10789920" cy="777240"/>
+          </a:xfrm>
+          <a:prstGeom prst="rect">
+            <a:avLst/>
+          </a:prstGeom>
+          <a:noFill/>
+        </p:spPr>
+        <p:txBody>
+          <a:bodyPr wrap="square">
+            <a:spAutoFit/>
+          </a:bodyPr>
+          <a:lstStyle/>
+          <a:p>
+            <a:r>
+              <a:rPr sz="3000" b="1">
+                <a:solidFill>
+                  <a:srgbClr val="0F203C"/>
+                </a:solidFill>
+              </a:rPr>
               <a:t>Casos de uso de alto riesgo</a:t>
             </a:r>
           </a:p>
@@ -4341,15 +4613,15 @@
       </p:sp>
       <p:graphicFrame>
         <p:nvGraphicFramePr>
-          <p:cNvPr id="3" name="Table 2"/>
+          <p:cNvPr id="4" name="Table 3"/>
           <p:cNvGraphicFramePr>
             <a:graphicFrameLocks noGrp="1"/>
           </p:cNvGraphicFramePr>
           <p:nvPr/>
         </p:nvGraphicFramePr>
         <p:xfrm>
-          <a:off x="365760" y="1554480"/>
-          <a:ext cx="8412480" cy="3474720"/>
+          <a:off x="548640" y="1554480"/>
+          <a:ext cx="11064240" cy="3474720"/>
         </p:xfrm>
         <a:graphic>
           <a:graphicData uri="http://schemas.openxmlformats.org/drawingml/2006/table">
@@ -4358,9 +4630,9 @@
                 <a:tableStyleId>{5C22544A-7EE6-4342-B048-85BDC9FD1C3A}</a:tableStyleId>
               </a:tblPr>
               <a:tblGrid>
-                <a:gridCol w="2804160"/>
-                <a:gridCol w="2804160"/>
-                <a:gridCol w="2804160"/>
+                <a:gridCol w="3688080"/>
+                <a:gridCol w="3688080"/>
+                <a:gridCol w="3688080"/>
               </a:tblGrid>
               <a:tr h="1158240">
                 <a:tc>
@@ -4369,7 +4641,7 @@
                     <a:lstStyle/>
                     <a:p>
                       <a:r>
-                        <a:rPr sz="1400" b="1"/>
+                        <a:rPr sz="1500" b="1"/>
                         <a:t>Caso de uso (riesgo alto)</a:t>
                       </a:r>
                     </a:p>
@@ -4386,7 +4658,7 @@
                     <a:lstStyle/>
                     <a:p>
                       <a:r>
-                        <a:rPr sz="1400" b="1"/>
+                        <a:rPr sz="1500" b="1"/>
                         <a:t>Descripción</a:t>
                       </a:r>
                     </a:p>
@@ -4403,7 +4675,7 @@
                     <a:lstStyle/>
                     <a:p>
                       <a:r>
-                        <a:rPr sz="1400" b="1"/>
+                        <a:rPr sz="1500" b="1"/>
                         <a:t>Quién lo cubre</a:t>
                       </a:r>
                     </a:p>
@@ -4422,7 +4694,7 @@
                     <a:lstStyle/>
                     <a:p>
                       <a:r>
-                        <a:rPr sz="1200"/>
+                        <a:rPr sz="1300"/>
                         <a:t>Cribado automático de candidaturas</a:t>
                       </a:r>
                     </a:p>
@@ -4439,7 +4711,7 @@
                     <a:lstStyle/>
                     <a:p>
                       <a:r>
-                        <a:rPr sz="1200"/>
+                        <a:rPr sz="1300"/>
                         <a:t>Sistema de apoyo a decisiones de contratación; alto impacto en personas y obligaciones de equidad y transparencia.</a:t>
                       </a:r>
                     </a:p>
@@ -4456,7 +4728,7 @@
                     <a:lstStyle/>
                     <a:p>
                       <a:r>
-                        <a:rPr sz="1200"/>
+                        <a:rPr sz="1300"/>
                         <a:t>Lucía Marín (60%), Yuki Tanaka (30%), Bruno Salgado (25%)</a:t>
                       </a:r>
                     </a:p>
@@ -4475,7 +4747,7 @@
                     <a:lstStyle/>
                     <a:p>
                       <a:r>
-                        <a:rPr sz="1200"/>
+                        <a:rPr sz="1300"/>
                         <a:t>Triaje clínico asistido</a:t>
                       </a:r>
                     </a:p>
@@ -4492,7 +4764,7 @@
                     <a:lstStyle/>
                     <a:p>
                       <a:r>
-                        <a:rPr sz="1200"/>
+                        <a:rPr sz="1300"/>
                         <a:t>Recomendación de prioridad en atención sanitaria; alto riesgo, requiere validación clínica y trazabilidad.</a:t>
                       </a:r>
                     </a:p>
@@ -4509,7 +4781,7 @@
                     <a:lstStyle/>
                     <a:p>
                       <a:r>
-                        <a:rPr sz="1200"/>
+                        <a:rPr sz="1300"/>
                         <a:t>Aisha Nassiri (70%), Yuki Tanaka (40%)</a:t>
                       </a:r>
                     </a:p>
@@ -4527,14 +4799,14 @@
       </p:graphicFrame>
       <p:sp>
         <p:nvSpPr>
-          <p:cNvPr id="4" name="TextBox 3"/>
+          <p:cNvPr id="5" name="TextBox 4"/>
           <p:cNvSpPr txBox="1"/>
           <p:nvPr/>
         </p:nvSpPr>
         <p:spPr>
           <a:xfrm>
-            <a:off x="365760" y="5303520"/>
-            <a:ext cx="8412480" cy="731520"/>
+            <a:off x="548640" y="5303520"/>
+            <a:ext cx="11064240" cy="640080"/>
           </a:xfrm>
           <a:prstGeom prst="rect">
             <a:avLst/>

</xml_diff>